<commit_message>
Add 초3 국어 lessons 2-7; word-level wrapping and figure text checks
- lessons: 문맥으로 낱말 뜻 짐작, 국어사전 찾기, 조사한 내용 발표하기,
  문단 쓰기, 마음을 전하는 편지, 인물의 마음과 까닭 (checks pass,
  previews reviewed)
- builder: Korean words no longer break mid-word (eaLnBrk=0), matching
  the fit estimate; flow, word-card and table text is fit-checked;
  passage paragraphs can be right-aligned (letter date and signature)
- worksheet: empty table cells keep a writable width
- plan: 조사한 내용 발표하기 now requires 일이 일어난 차례 (초2)
- all finished lessons rebuilt with the updated tools

Co-Authored-By: Claude Opus 5.5 <noreply@anthropic.com>
Claude-Session: https://claude.ai/code/session_01EDFMZ4KdXfygs8AmnQ2tjw
</commit_message>
<xml_diff>
--- a/dist/초1/수학/수와연산/초1_수학_수와연산_01_9까지의수.pptx
+++ b/dist/초1/수학/수와연산/초1_수학_수와연산_01_9까지의수.pptx
@@ -119,13 +119,13 @@
   <p:extLst>
     <p:ext uri="{521415D9-36F7-43E2-AB2F-B90AF26B5E84}">
       <p14:sectionLst xmlns:p14="http://schemas.microsoft.com/office/powerpoint/2010/main">
-        <p14:section name="도입" id="{c66b6d40-c1b3-accb-05d7-ccd6ab61cc3e}">
+        <p14:section name="도입" id="{56e98aeb-2328-0ab2-0aba-37ce48060b90}">
           <p14:sldIdLst>
             <p14:sldId id="256"/>
             <p14:sldId id="257"/>
           </p14:sldIdLst>
         </p14:section>
-        <p14:section name="개념" id="{c26cf877-32e9-8cb2-a48d-ba158b9560f2}">
+        <p14:section name="개념" id="{46b7b5ab-1688-f46d-e8dc-a76a9dd7f2a0}">
           <p14:sldIdLst>
             <p14:sldId id="258"/>
             <p14:sldId id="259"/>
@@ -134,24 +134,24 @@
             <p14:sldId id="262"/>
           </p14:sldIdLst>
         </p14:section>
-        <p14:section name="연습" id="{888d4ea3-39d3-b96b-d358-7162fbabc02b}">
+        <p14:section name="연습" id="{66f5cafb-e391-a74f-9e8f-0f368071160b}">
           <p14:sldIdLst>
             <p14:sldId id="263"/>
             <p14:sldId id="264"/>
           </p14:sldIdLst>
         </p14:section>
-        <p14:section name="확인" id="{473f7b6e-ddd5-987e-66aa-04f99c055045}">
+        <p14:section name="확인" id="{c16beeab-f3a2-65ca-bdf5-c64a95f62805}">
           <p14:sldIdLst>
             <p14:sldId id="265"/>
             <p14:sldId id="266"/>
           </p14:sldIdLst>
         </p14:section>
-        <p14:section name="정리" id="{bfbac797-4afb-c3d4-578e-c1f717ad0c03}">
+        <p14:section name="정리" id="{02506a0a-bd01-06b4-8fd4-c897cad3cc8f}">
           <p14:sldIdLst>
             <p14:sldId id="267"/>
           </p14:sldIdLst>
         </p14:section>
-        <p14:section name="보충" id="{dc5419bb-df5d-b09e-0ad8-16972f40ea56}">
+        <p14:section name="보충" id="{4e98ceab-4952-a9b0-9efa-a26133d5e011}">
           <p14:sldIdLst>
             <p14:sldId id="268"/>
           </p14:sldIdLst>
@@ -2823,7 +2823,7 @@
           <a:bodyPr wrap="square" lIns="0" tIns="0" rIns="0" bIns="0" rtlCol="0" anchor="ctr"/>
           <a:lstStyle/>
           <a:p>
-            <a:pPr algn="l" indent="0" marL="0">
+            <a:pPr eaLnBrk="0" algn="l" indent="0" marL="0">
               <a:buNone/>
             </a:pPr>
             <a:r>
@@ -2864,7 +2864,7 @@
           <a:bodyPr wrap="square" lIns="0" tIns="0" rIns="0" bIns="0" rtlCol="0" anchor="t"/>
           <a:lstStyle/>
           <a:p>
-            <a:pPr indent="0" marL="0">
+            <a:pPr eaLnBrk="0" indent="0" marL="0">
               <a:buNone/>
             </a:pPr>
             <a:r>
@@ -3309,7 +3309,7 @@
       </p:sp>
       <p:sp>
         <p:nvSpPr>
-          <p:cNvPr id="21" name="S01-figure18" descr="십 칸 틀에 7개"/>
+          <p:cNvPr id="21" name="S01-figure18" descr="1개의 십 칸 틀 중 1번째: 모두 7개"/>
           <p:cNvSpPr/>
           <p:nvPr/>
         </p:nvSpPr>
@@ -3382,7 +3382,7 @@
           <a:bodyPr wrap="square" lIns="0" tIns="0" rIns="0" bIns="0" rtlCol="0" anchor="ctr"/>
           <a:lstStyle/>
           <a:p>
-            <a:pPr indent="0" marL="0">
+            <a:pPr eaLnBrk="0" indent="0" marL="0">
               <a:spcAft>
                 <a:spcPts val="600"/>
               </a:spcAft>
@@ -3402,7 +3402,7 @@
             <a:endParaRPr lang="ko-KR" sz="3200" dirty="0"/>
           </a:p>
           <a:p>
-            <a:pPr indent="0" marL="0">
+            <a:pPr eaLnBrk="0" indent="0" marL="0">
               <a:spcAft>
                 <a:spcPts val="600"/>
               </a:spcAft>
@@ -3422,7 +3422,7 @@
             <a:endParaRPr lang="ko-KR" sz="3200" dirty="0"/>
           </a:p>
           <a:p>
-            <a:pPr indent="0" marL="0">
+            <a:pPr eaLnBrk="0" indent="0" marL="0">
               <a:spcAft>
                 <a:spcPts val="600"/>
               </a:spcAft>
@@ -3491,7 +3491,7 @@
           <a:bodyPr wrap="square" lIns="0" tIns="0" rIns="0" bIns="0" rtlCol="0" anchor="ctr"/>
           <a:lstStyle/>
           <a:p>
-            <a:pPr algn="l" indent="0" marL="0">
+            <a:pPr eaLnBrk="0" algn="l" indent="0" marL="0">
               <a:buNone/>
             </a:pPr>
             <a:r>
@@ -3530,7 +3530,7 @@
           <a:bodyPr wrap="square" lIns="0" tIns="0" rIns="0" bIns="0" rtlCol="0" anchor="ctr"/>
           <a:lstStyle/>
           <a:p>
-            <a:pPr algn="l" indent="0" marL="0">
+            <a:pPr eaLnBrk="0" algn="l" indent="0" marL="0">
               <a:buNone/>
             </a:pPr>
             <a:r>
@@ -3577,7 +3577,7 @@
           <a:bodyPr wrap="square" lIns="0" tIns="0" rIns="0" bIns="0" rtlCol="0" anchor="ctr"/>
           <a:lstStyle/>
           <a:p>
-            <a:pPr algn="ctr" indent="0" marL="0">
+            <a:pPr eaLnBrk="0" algn="ctr" indent="0" marL="0">
               <a:buNone/>
             </a:pPr>
             <a:r>
@@ -3616,7 +3616,7 @@
           <a:bodyPr wrap="square" lIns="0" tIns="0" rIns="0" bIns="0" rtlCol="0" anchor="ctr"/>
           <a:lstStyle/>
           <a:p>
-            <a:pPr algn="l" indent="0" marL="0">
+            <a:pPr eaLnBrk="0" algn="l" indent="0" marL="0">
               <a:buNone/>
             </a:pPr>
             <a:r>
@@ -3663,7 +3663,7 @@
           <a:bodyPr wrap="square" lIns="0" tIns="0" rIns="0" bIns="0" rtlCol="0" anchor="ctr"/>
           <a:lstStyle/>
           <a:p>
-            <a:pPr algn="ctr" indent="0" marL="0">
+            <a:pPr eaLnBrk="0" algn="ctr" indent="0" marL="0">
               <a:buNone/>
             </a:pPr>
             <a:r>
@@ -3702,7 +3702,7 @@
           <a:bodyPr wrap="square" lIns="0" tIns="0" rIns="0" bIns="0" rtlCol="0" anchor="ctr"/>
           <a:lstStyle/>
           <a:p>
-            <a:pPr algn="l" indent="0" marL="0">
+            <a:pPr eaLnBrk="0" algn="l" indent="0" marL="0">
               <a:buNone/>
             </a:pPr>
             <a:r>
@@ -3749,7 +3749,7 @@
           <a:bodyPr wrap="square" lIns="0" tIns="0" rIns="0" bIns="0" rtlCol="0" anchor="ctr"/>
           <a:lstStyle/>
           <a:p>
-            <a:pPr algn="ctr" indent="0" marL="0">
+            <a:pPr eaLnBrk="0" algn="ctr" indent="0" marL="0">
               <a:buNone/>
             </a:pPr>
             <a:r>
@@ -3788,7 +3788,7 @@
           <a:bodyPr wrap="square" lIns="0" tIns="0" rIns="0" bIns="0" rtlCol="0" anchor="ctr"/>
           <a:lstStyle/>
           <a:p>
-            <a:pPr algn="l" indent="0" marL="0">
+            <a:pPr eaLnBrk="0" algn="l" indent="0" marL="0">
               <a:buNone/>
             </a:pPr>
             <a:r>
@@ -3845,7 +3845,7 @@
             </a:lvl1pPr>
           </a:lstStyle>
           <a:p>
-            <a:pPr algn="r"/>
+            <a:pPr eaLnBrk="0" algn="r"/>
             <a:fld id="{F7021451-1387-4CA6-816F-3879F97B5CBC}" type="slidenum">
               <a:rPr b="0" lang="en-US"/>
               <a:t>10</a:t>
@@ -3902,7 +3902,7 @@
           <a:bodyPr wrap="square" lIns="0" tIns="0" rIns="0" bIns="0" rtlCol="0" anchor="ctr"/>
           <a:lstStyle/>
           <a:p>
-            <a:pPr algn="l" indent="0" marL="0">
+            <a:pPr eaLnBrk="0" algn="l" indent="0" marL="0">
               <a:buNone/>
             </a:pPr>
             <a:r>
@@ -3968,7 +3968,7 @@
           <a:bodyPr wrap="square" lIns="0" tIns="0" rIns="0" bIns="0" rtlCol="0" anchor="ctr"/>
           <a:lstStyle/>
           <a:p>
-            <a:pPr indent="0" marL="0">
+            <a:pPr eaLnBrk="0" indent="0" marL="0">
               <a:spcAft>
                 <a:spcPts val="600"/>
               </a:spcAft>
@@ -4018,7 +4018,7 @@
           <a:bodyPr wrap="square" lIns="0" tIns="0" rIns="0" bIns="0" rtlCol="0" anchor="ctr"/>
           <a:lstStyle/>
           <a:p>
-            <a:pPr algn="ctr" indent="0" marL="0">
+            <a:pPr eaLnBrk="0" algn="ctr" indent="0" marL="0">
               <a:buNone/>
             </a:pPr>
             <a:r>
@@ -4438,7 +4438,7 @@
       </p:sp>
       <p:sp>
         <p:nvSpPr>
-          <p:cNvPr id="22" name="S11-figure277" descr="십 칸 틀에 6개"/>
+          <p:cNvPr id="22" name="S11-figure277" descr="1개의 십 칸 틀 중 1번째: 모두 6개"/>
           <p:cNvSpPr/>
           <p:nvPr/>
         </p:nvSpPr>
@@ -4492,7 +4492,7 @@
           <a:bodyPr wrap="square" lIns="0" tIns="0" rIns="0" bIns="0" rtlCol="0" anchor="ctr"/>
           <a:lstStyle/>
           <a:p>
-            <a:pPr algn="ctr" indent="0" marL="0">
+            <a:pPr eaLnBrk="0" algn="ctr" indent="0" marL="0">
               <a:buNone/>
             </a:pPr>
             <a:r>
@@ -4987,7 +4987,7 @@
       </p:sp>
       <p:sp>
         <p:nvSpPr>
-          <p:cNvPr id="43" name="S11-figure298" descr="십 칸 틀에 9개"/>
+          <p:cNvPr id="43" name="S11-figure298" descr="1개의 십 칸 틀 중 1번째: 모두 9개"/>
           <p:cNvSpPr/>
           <p:nvPr/>
         </p:nvSpPr>
@@ -5041,7 +5041,7 @@
           <a:bodyPr wrap="square" lIns="0" tIns="0" rIns="0" bIns="0" rtlCol="0" anchor="ctr"/>
           <a:lstStyle/>
           <a:p>
-            <a:pPr algn="ctr" indent="0" marL="0">
+            <a:pPr eaLnBrk="0" algn="ctr" indent="0" marL="0">
               <a:buNone/>
             </a:pPr>
             <a:r>
@@ -5252,7 +5252,7 @@
             </a:lvl1pPr>
           </a:lstStyle>
           <a:p>
-            <a:pPr algn="r"/>
+            <a:pPr eaLnBrk="0" algn="r"/>
             <a:fld id="{F7021451-1387-4CA6-816F-3879F97B5CBC}" type="slidenum">
               <a:rPr b="0" lang="en-US"/>
               <a:t>11</a:t>
@@ -5309,7 +5309,7 @@
           <a:bodyPr wrap="square" lIns="0" tIns="0" rIns="0" bIns="0" rtlCol="0" anchor="ctr"/>
           <a:lstStyle/>
           <a:p>
-            <a:pPr algn="l" indent="0" marL="0">
+            <a:pPr eaLnBrk="0" algn="l" indent="0" marL="0">
               <a:buNone/>
             </a:pPr>
             <a:r>
@@ -5375,7 +5375,7 @@
           <a:bodyPr wrap="square" lIns="0" tIns="0" rIns="0" bIns="0" rtlCol="0" anchor="ctr"/>
           <a:lstStyle/>
           <a:p>
-            <a:pPr indent="0" marL="0">
+            <a:pPr eaLnBrk="0" indent="0" marL="0">
               <a:spcAft>
                 <a:spcPts val="600"/>
               </a:spcAft>
@@ -5425,7 +5425,7 @@
           <a:bodyPr wrap="square" lIns="177800" tIns="0" rIns="177800" bIns="0" rtlCol="0" anchor="ctr"/>
           <a:lstStyle/>
           <a:p>
-            <a:pPr algn="l" indent="0" marL="0">
+            <a:pPr eaLnBrk="0" algn="l" indent="0" marL="0">
               <a:buNone/>
             </a:pPr>
             <a:r>
@@ -5472,7 +5472,7 @@
           <a:bodyPr wrap="square" lIns="177800" tIns="0" rIns="177800" bIns="0" rtlCol="0" anchor="ctr"/>
           <a:lstStyle/>
           <a:p>
-            <a:pPr algn="l" indent="0" marL="0">
+            <a:pPr eaLnBrk="0" algn="l" indent="0" marL="0">
               <a:buNone/>
             </a:pPr>
             <a:r>
@@ -5511,7 +5511,7 @@
           <a:bodyPr wrap="square" lIns="0" tIns="0" rIns="0" bIns="0" rtlCol="0" anchor="t"/>
           <a:lstStyle/>
           <a:p>
-            <a:pPr algn="l" indent="0" marL="0">
+            <a:pPr eaLnBrk="0" algn="l" indent="0" marL="0">
               <a:buNone/>
             </a:pPr>
             <a:r>
@@ -5550,7 +5550,7 @@
           <a:bodyPr wrap="square" lIns="0" tIns="0" rIns="0" bIns="0" rtlCol="0" anchor="ctr"/>
           <a:lstStyle/>
           <a:p>
-            <a:pPr algn="l" indent="0" marL="0">
+            <a:pPr eaLnBrk="0" algn="l" indent="0" marL="0">
               <a:buNone/>
             </a:pPr>
             <a:r>
@@ -5589,7 +5589,7 @@
           <a:bodyPr wrap="square" lIns="0" tIns="0" rIns="0" bIns="0" rtlCol="0" anchor="ctr"/>
           <a:lstStyle/>
           <a:p>
-            <a:pPr algn="l" indent="0" marL="0">
+            <a:pPr eaLnBrk="0" algn="l" indent="0" marL="0">
               <a:buNone/>
             </a:pPr>
             <a:r>
@@ -5628,7 +5628,7 @@
           <a:bodyPr wrap="square" lIns="0" tIns="0" rIns="0" bIns="0" rtlCol="0" anchor="ctr"/>
           <a:lstStyle/>
           <a:p>
-            <a:pPr algn="l" indent="0" marL="0">
+            <a:pPr eaLnBrk="0" algn="l" indent="0" marL="0">
               <a:buNone/>
             </a:pPr>
             <a:r>
@@ -5667,7 +5667,7 @@
           <a:bodyPr wrap="square" lIns="0" tIns="0" rIns="0" bIns="0" rtlCol="0" anchor="ctr"/>
           <a:lstStyle/>
           <a:p>
-            <a:pPr algn="l" indent="0" marL="0">
+            <a:pPr eaLnBrk="0" algn="l" indent="0" marL="0">
               <a:buNone/>
             </a:pPr>
             <a:r>
@@ -5724,7 +5724,7 @@
             </a:lvl1pPr>
           </a:lstStyle>
           <a:p>
-            <a:pPr algn="r"/>
+            <a:pPr eaLnBrk="0" algn="r"/>
             <a:fld id="{F7021451-1387-4CA6-816F-3879F97B5CBC}" type="slidenum">
               <a:rPr b="0" lang="en-US"/>
               <a:t>12</a:t>
@@ -5781,7 +5781,7 @@
           <a:bodyPr wrap="square" lIns="0" tIns="0" rIns="0" bIns="0" rtlCol="0" anchor="ctr"/>
           <a:lstStyle/>
           <a:p>
-            <a:pPr algn="l" indent="0" marL="0">
+            <a:pPr eaLnBrk="0" algn="l" indent="0" marL="0">
               <a:buNone/>
             </a:pPr>
             <a:r>
@@ -5847,7 +5847,7 @@
           <a:bodyPr wrap="square" lIns="0" tIns="0" rIns="0" bIns="0" rtlCol="0" anchor="ctr"/>
           <a:lstStyle/>
           <a:p>
-            <a:pPr indent="0" marL="0">
+            <a:pPr eaLnBrk="0" indent="0" marL="0">
               <a:spcAft>
                 <a:spcPts val="600"/>
               </a:spcAft>
@@ -6018,7 +6018,7 @@
           <a:bodyPr wrap="square" lIns="0" tIns="0" rIns="0" bIns="0" rtlCol="0" anchor="ctr"/>
           <a:lstStyle/>
           <a:p>
-            <a:pPr algn="ctr" indent="0" marL="0">
+            <a:pPr eaLnBrk="0" algn="ctr" indent="0" marL="0">
               <a:buNone/>
             </a:pPr>
             <a:r>
@@ -6211,7 +6211,7 @@
           <a:bodyPr wrap="square" lIns="0" tIns="0" rIns="0" bIns="0" rtlCol="0" anchor="ctr"/>
           <a:lstStyle/>
           <a:p>
-            <a:pPr algn="ctr" indent="0" marL="0">
+            <a:pPr eaLnBrk="0" algn="ctr" indent="0" marL="0">
               <a:buNone/>
             </a:pPr>
             <a:r>
@@ -6268,7 +6268,7 @@
             </a:lvl1pPr>
           </a:lstStyle>
           <a:p>
-            <a:pPr algn="r"/>
+            <a:pPr eaLnBrk="0" algn="r"/>
             <a:fld id="{F7021451-1387-4CA6-816F-3879F97B5CBC}" type="slidenum">
               <a:rPr b="0" lang="en-US"/>
               <a:t>13</a:t>
@@ -6325,7 +6325,7 @@
           <a:bodyPr wrap="square" lIns="0" tIns="0" rIns="0" bIns="0" rtlCol="0" anchor="ctr"/>
           <a:lstStyle/>
           <a:p>
-            <a:pPr algn="l" indent="0" marL="0">
+            <a:pPr eaLnBrk="0" algn="l" indent="0" marL="0">
               <a:buNone/>
             </a:pPr>
             <a:r>
@@ -6391,7 +6391,7 @@
           <a:bodyPr wrap="square" lIns="0" tIns="0" rIns="0" bIns="0" rtlCol="0" anchor="ctr"/>
           <a:lstStyle/>
           <a:p>
-            <a:pPr indent="0" marL="0">
+            <a:pPr eaLnBrk="0" indent="0" marL="0">
               <a:spcAft>
                 <a:spcPts val="600"/>
               </a:spcAft>
@@ -6441,7 +6441,7 @@
           <a:bodyPr wrap="square" lIns="0" tIns="0" rIns="0" bIns="0" rtlCol="0" anchor="ctr"/>
           <a:lstStyle/>
           <a:p>
-            <a:pPr algn="ctr" indent="0" marL="0">
+            <a:pPr eaLnBrk="0" algn="ctr" indent="0" marL="0">
               <a:buNone/>
             </a:pPr>
             <a:r>
@@ -6617,7 +6617,7 @@
           <a:bodyPr wrap="square" lIns="0" tIns="0" rIns="0" bIns="0" rtlCol="0" anchor="ctr"/>
           <a:lstStyle/>
           <a:p>
-            <a:pPr algn="ctr" indent="0" marL="0">
+            <a:pPr eaLnBrk="0" algn="ctr" indent="0" marL="0">
               <a:buNone/>
             </a:pPr>
             <a:r>
@@ -6853,7 +6853,7 @@
             </a:lvl1pPr>
           </a:lstStyle>
           <a:p>
-            <a:pPr algn="r"/>
+            <a:pPr eaLnBrk="0" algn="r"/>
             <a:fld id="{F7021451-1387-4CA6-816F-3879F97B5CBC}" type="slidenum">
               <a:rPr b="0" lang="en-US"/>
               <a:t>2</a:t>
@@ -6910,7 +6910,7 @@
           <a:bodyPr wrap="square" lIns="0" tIns="0" rIns="0" bIns="0" rtlCol="0" anchor="ctr"/>
           <a:lstStyle/>
           <a:p>
-            <a:pPr algn="l" indent="0" marL="0">
+            <a:pPr eaLnBrk="0" algn="l" indent="0" marL="0">
               <a:buNone/>
             </a:pPr>
             <a:r>
@@ -6976,7 +6976,7 @@
           <a:bodyPr wrap="square" lIns="0" tIns="0" rIns="0" bIns="0" rtlCol="0" anchor="ctr"/>
           <a:lstStyle/>
           <a:p>
-            <a:pPr indent="0" marL="0">
+            <a:pPr eaLnBrk="0" indent="0" marL="0">
               <a:spcAft>
                 <a:spcPts val="600"/>
               </a:spcAft>
@@ -7199,7 +7199,7 @@
           <a:bodyPr wrap="square" lIns="0" tIns="0" rIns="0" bIns="0" rtlCol="0" anchor="ctr"/>
           <a:lstStyle/>
           <a:p>
-            <a:pPr indent="0" marL="0">
+            <a:pPr eaLnBrk="0" indent="0" marL="0">
               <a:spcAft>
                 <a:spcPts val="600"/>
               </a:spcAft>
@@ -7268,7 +7268,7 @@
           <a:bodyPr wrap="square" lIns="0" tIns="0" rIns="0" bIns="0" rtlCol="0" anchor="ctr"/>
           <a:lstStyle/>
           <a:p>
-            <a:pPr indent="0" marL="0">
+            <a:pPr eaLnBrk="0" indent="0" marL="0">
               <a:spcAft>
                 <a:spcPts val="600"/>
               </a:spcAft>
@@ -7328,7 +7328,7 @@
             </a:lvl1pPr>
           </a:lstStyle>
           <a:p>
-            <a:pPr algn="r"/>
+            <a:pPr eaLnBrk="0" algn="r"/>
             <a:fld id="{F7021451-1387-4CA6-816F-3879F97B5CBC}" type="slidenum">
               <a:rPr b="0" lang="en-US"/>
               <a:t>3</a:t>
@@ -7385,7 +7385,7 @@
           <a:bodyPr wrap="square" lIns="0" tIns="0" rIns="0" bIns="0" rtlCol="0" anchor="ctr"/>
           <a:lstStyle/>
           <a:p>
-            <a:pPr algn="l" indent="0" marL="0">
+            <a:pPr eaLnBrk="0" algn="l" indent="0" marL="0">
               <a:buNone/>
             </a:pPr>
             <a:r>
@@ -7451,7 +7451,7 @@
           <a:bodyPr wrap="square" lIns="0" tIns="0" rIns="0" bIns="0" rtlCol="0" anchor="ctr"/>
           <a:lstStyle/>
           <a:p>
-            <a:pPr indent="0" marL="0">
+            <a:pPr eaLnBrk="0" indent="0" marL="0">
               <a:spcAft>
                 <a:spcPts val="600"/>
               </a:spcAft>
@@ -7547,7 +7547,7 @@
           <a:bodyPr wrap="square" lIns="0" tIns="0" rIns="0" bIns="0" rtlCol="0" anchor="ctr"/>
           <a:lstStyle/>
           <a:p>
-            <a:pPr algn="ctr" indent="0" marL="0">
+            <a:pPr eaLnBrk="0" algn="ctr" indent="0" marL="0">
               <a:buNone/>
             </a:pPr>
             <a:r>
@@ -7665,7 +7665,7 @@
           <a:bodyPr wrap="square" lIns="0" tIns="0" rIns="0" bIns="0" rtlCol="0" anchor="ctr"/>
           <a:lstStyle/>
           <a:p>
-            <a:pPr algn="ctr" indent="0" marL="0">
+            <a:pPr eaLnBrk="0" algn="ctr" indent="0" marL="0">
               <a:buNone/>
             </a:pPr>
             <a:r>
@@ -7808,7 +7808,7 @@
           <a:bodyPr wrap="square" lIns="0" tIns="0" rIns="0" bIns="0" rtlCol="0" anchor="ctr"/>
           <a:lstStyle/>
           <a:p>
-            <a:pPr algn="ctr" indent="0" marL="0">
+            <a:pPr eaLnBrk="0" algn="ctr" indent="0" marL="0">
               <a:buNone/>
             </a:pPr>
             <a:r>
@@ -7976,7 +7976,7 @@
           <a:bodyPr wrap="square" lIns="0" tIns="0" rIns="0" bIns="0" rtlCol="0" anchor="ctr"/>
           <a:lstStyle/>
           <a:p>
-            <a:pPr algn="ctr" indent="0" marL="0">
+            <a:pPr eaLnBrk="0" algn="ctr" indent="0" marL="0">
               <a:buNone/>
             </a:pPr>
             <a:r>
@@ -8169,7 +8169,7 @@
           <a:bodyPr wrap="square" lIns="0" tIns="0" rIns="0" bIns="0" rtlCol="0" anchor="ctr"/>
           <a:lstStyle/>
           <a:p>
-            <a:pPr algn="ctr" indent="0" marL="0">
+            <a:pPr eaLnBrk="0" algn="ctr" indent="0" marL="0">
               <a:buNone/>
             </a:pPr>
             <a:r>
@@ -8226,7 +8226,7 @@
             </a:lvl1pPr>
           </a:lstStyle>
           <a:p>
-            <a:pPr algn="r"/>
+            <a:pPr eaLnBrk="0" algn="r"/>
             <a:fld id="{F7021451-1387-4CA6-816F-3879F97B5CBC}" type="slidenum">
               <a:rPr b="0" lang="en-US"/>
               <a:t>4</a:t>
@@ -8283,7 +8283,7 @@
           <a:bodyPr wrap="square" lIns="0" tIns="0" rIns="0" bIns="0" rtlCol="0" anchor="ctr"/>
           <a:lstStyle/>
           <a:p>
-            <a:pPr algn="l" indent="0" marL="0">
+            <a:pPr eaLnBrk="0" algn="l" indent="0" marL="0">
               <a:buNone/>
             </a:pPr>
             <a:r>
@@ -8349,7 +8349,7 @@
           <a:bodyPr wrap="square" lIns="0" tIns="0" rIns="0" bIns="0" rtlCol="0" anchor="ctr"/>
           <a:lstStyle/>
           <a:p>
-            <a:pPr indent="0" marL="0">
+            <a:pPr eaLnBrk="0" indent="0" marL="0">
               <a:spcAft>
                 <a:spcPts val="600"/>
               </a:spcAft>
@@ -8772,7 +8772,7 @@
       </p:sp>
       <p:sp>
         <p:nvSpPr>
-          <p:cNvPr id="21" name="S05-figure94" descr="십 칸 틀에 6개"/>
+          <p:cNvPr id="21" name="S05-figure94" descr="1개의 십 칸 틀 중 1번째: 모두 6개"/>
           <p:cNvSpPr/>
           <p:nvPr/>
         </p:nvSpPr>
@@ -8818,7 +8818,7 @@
           <a:bodyPr wrap="square" lIns="0" tIns="0" rIns="0" bIns="0" rtlCol="0" anchor="ctr"/>
           <a:lstStyle/>
           <a:p>
-            <a:pPr algn="ctr" indent="0" marL="0">
+            <a:pPr eaLnBrk="0" algn="ctr" indent="0" marL="0">
               <a:buNone/>
             </a:pPr>
             <a:r>
@@ -9263,7 +9263,7 @@
       </p:sp>
       <p:sp>
         <p:nvSpPr>
-          <p:cNvPr id="40" name="S05-figure113" descr="십 칸 틀에 7개"/>
+          <p:cNvPr id="40" name="S05-figure113" descr="1개의 십 칸 틀 중 1번째: 모두 7개"/>
           <p:cNvSpPr/>
           <p:nvPr/>
         </p:nvSpPr>
@@ -9309,7 +9309,7 @@
           <a:bodyPr wrap="square" lIns="0" tIns="0" rIns="0" bIns="0" rtlCol="0" anchor="ctr"/>
           <a:lstStyle/>
           <a:p>
-            <a:pPr algn="ctr" indent="0" marL="0">
+            <a:pPr eaLnBrk="0" algn="ctr" indent="0" marL="0">
               <a:buNone/>
             </a:pPr>
             <a:r>
@@ -9779,7 +9779,7 @@
       </p:sp>
       <p:sp>
         <p:nvSpPr>
-          <p:cNvPr id="60" name="S05-figure133" descr="십 칸 틀에 8개"/>
+          <p:cNvPr id="60" name="S05-figure133" descr="1개의 십 칸 틀 중 1번째: 모두 8개"/>
           <p:cNvSpPr/>
           <p:nvPr/>
         </p:nvSpPr>
@@ -9825,7 +9825,7 @@
           <a:bodyPr wrap="square" lIns="0" tIns="0" rIns="0" bIns="0" rtlCol="0" anchor="ctr"/>
           <a:lstStyle/>
           <a:p>
-            <a:pPr algn="ctr" indent="0" marL="0">
+            <a:pPr eaLnBrk="0" algn="ctr" indent="0" marL="0">
               <a:buNone/>
             </a:pPr>
             <a:r>
@@ -10320,7 +10320,7 @@
       </p:sp>
       <p:sp>
         <p:nvSpPr>
-          <p:cNvPr id="81" name="S05-figure154" descr="십 칸 틀에 9개"/>
+          <p:cNvPr id="81" name="S05-figure154" descr="1개의 십 칸 틀 중 1번째: 모두 9개"/>
           <p:cNvSpPr/>
           <p:nvPr/>
         </p:nvSpPr>
@@ -10366,7 +10366,7 @@
           <a:bodyPr wrap="square" lIns="0" tIns="0" rIns="0" bIns="0" rtlCol="0" anchor="ctr"/>
           <a:lstStyle/>
           <a:p>
-            <a:pPr algn="ctr" indent="0" marL="0">
+            <a:pPr eaLnBrk="0" algn="ctr" indent="0" marL="0">
               <a:buNone/>
             </a:pPr>
             <a:r>
@@ -10423,7 +10423,7 @@
             </a:lvl1pPr>
           </a:lstStyle>
           <a:p>
-            <a:pPr algn="r"/>
+            <a:pPr eaLnBrk="0" algn="r"/>
             <a:fld id="{F7021451-1387-4CA6-816F-3879F97B5CBC}" type="slidenum">
               <a:rPr b="0" lang="en-US"/>
               <a:t>5</a:t>
@@ -10480,7 +10480,7 @@
           <a:bodyPr wrap="square" lIns="0" tIns="0" rIns="0" bIns="0" rtlCol="0" anchor="ctr"/>
           <a:lstStyle/>
           <a:p>
-            <a:pPr algn="l" indent="0" marL="0">
+            <a:pPr eaLnBrk="0" algn="l" indent="0" marL="0">
               <a:buNone/>
             </a:pPr>
             <a:r>
@@ -10546,7 +10546,7 @@
           <a:bodyPr wrap="square" lIns="0" tIns="0" rIns="0" bIns="0" rtlCol="0" anchor="ctr"/>
           <a:lstStyle/>
           <a:p>
-            <a:pPr indent="0" marL="0">
+            <a:pPr eaLnBrk="0" indent="0" marL="0">
               <a:spcAft>
                 <a:spcPts val="600"/>
               </a:spcAft>
@@ -10894,7 +10894,7 @@
       </p:sp>
       <p:sp>
         <p:nvSpPr>
-          <p:cNvPr id="18" name="S06-figure171" descr="십 칸 틀에 3개"/>
+          <p:cNvPr id="18" name="S06-figure171" descr="1개의 십 칸 틀 중 1번째: 모두 3개"/>
           <p:cNvSpPr/>
           <p:nvPr/>
         </p:nvSpPr>
@@ -10940,7 +10940,7 @@
           <a:bodyPr wrap="square" lIns="0" tIns="0" rIns="0" bIns="0" rtlCol="0" anchor="ctr"/>
           <a:lstStyle/>
           <a:p>
-            <a:pPr algn="ctr" indent="0" marL="0">
+            <a:pPr eaLnBrk="0" algn="ctr" indent="0" marL="0">
               <a:buNone/>
             </a:pPr>
             <a:r>
@@ -11210,7 +11210,7 @@
       </p:sp>
       <p:sp>
         <p:nvSpPr>
-          <p:cNvPr id="30" name="S06-figure183" descr="십 칸 틀에 0개"/>
+          <p:cNvPr id="30" name="S06-figure183" descr="1개의 십 칸 틀 중 1번째: 모두 0개"/>
           <p:cNvSpPr/>
           <p:nvPr/>
         </p:nvSpPr>
@@ -11256,7 +11256,7 @@
           <a:bodyPr wrap="square" lIns="0" tIns="0" rIns="0" bIns="0" rtlCol="0" anchor="ctr"/>
           <a:lstStyle/>
           <a:p>
-            <a:pPr algn="ctr" indent="0" marL="0">
+            <a:pPr eaLnBrk="0" algn="ctr" indent="0" marL="0">
               <a:buNone/>
             </a:pPr>
             <a:r>
@@ -11313,7 +11313,7 @@
             </a:lvl1pPr>
           </a:lstStyle>
           <a:p>
-            <a:pPr algn="r"/>
+            <a:pPr eaLnBrk="0" algn="r"/>
             <a:fld id="{F7021451-1387-4CA6-816F-3879F97B5CBC}" type="slidenum">
               <a:rPr b="0" lang="en-US"/>
               <a:t>6</a:t>
@@ -11370,7 +11370,7 @@
           <a:bodyPr wrap="square" lIns="0" tIns="0" rIns="0" bIns="0" rtlCol="0" anchor="ctr"/>
           <a:lstStyle/>
           <a:p>
-            <a:pPr algn="l" indent="0" marL="0">
+            <a:pPr eaLnBrk="0" algn="l" indent="0" marL="0">
               <a:buNone/>
             </a:pPr>
             <a:r>
@@ -11417,7 +11417,7 @@
           <a:bodyPr wrap="square" lIns="0" tIns="0" rIns="0" bIns="0" rtlCol="0" anchor="ctr"/>
           <a:lstStyle/>
           <a:p>
-            <a:pPr algn="ctr" indent="0" marL="0">
+            <a:pPr eaLnBrk="0" algn="ctr" indent="0" marL="0">
               <a:buNone/>
             </a:pPr>
             <a:r>
@@ -11464,7 +11464,7 @@
           <a:bodyPr wrap="square" lIns="0" tIns="0" rIns="0" bIns="0" rtlCol="0" anchor="ctr"/>
           <a:lstStyle/>
           <a:p>
-            <a:pPr algn="ctr" indent="0" marL="0">
+            <a:pPr eaLnBrk="0" algn="ctr" indent="0" marL="0">
               <a:buNone/>
             </a:pPr>
             <a:r>
@@ -11511,7 +11511,7 @@
           <a:bodyPr wrap="square" lIns="0" tIns="0" rIns="0" bIns="0" rtlCol="0" anchor="ctr"/>
           <a:lstStyle/>
           <a:p>
-            <a:pPr algn="ctr" indent="0" marL="0">
+            <a:pPr eaLnBrk="0" algn="ctr" indent="0" marL="0">
               <a:buNone/>
             </a:pPr>
             <a:r>
@@ -11558,7 +11558,7 @@
           <a:bodyPr wrap="square" lIns="0" tIns="0" rIns="0" bIns="0" rtlCol="0" anchor="ctr"/>
           <a:lstStyle/>
           <a:p>
-            <a:pPr algn="ctr" indent="0" marL="0">
+            <a:pPr eaLnBrk="0" algn="ctr" indent="0" marL="0">
               <a:buNone/>
             </a:pPr>
             <a:r>
@@ -11605,7 +11605,7 @@
           <a:bodyPr wrap="square" lIns="0" tIns="0" rIns="0" bIns="0" rtlCol="0" anchor="ctr"/>
           <a:lstStyle/>
           <a:p>
-            <a:pPr algn="ctr" indent="0" marL="0">
+            <a:pPr eaLnBrk="0" algn="ctr" indent="0" marL="0">
               <a:buNone/>
             </a:pPr>
             <a:r>
@@ -11652,7 +11652,7 @@
           <a:bodyPr wrap="square" lIns="0" tIns="0" rIns="0" bIns="0" rtlCol="0" anchor="ctr"/>
           <a:lstStyle/>
           <a:p>
-            <a:pPr algn="ctr" indent="0" marL="0">
+            <a:pPr eaLnBrk="0" algn="ctr" indent="0" marL="0">
               <a:buNone/>
             </a:pPr>
             <a:r>
@@ -11699,7 +11699,7 @@
           <a:bodyPr wrap="square" lIns="0" tIns="0" rIns="0" bIns="0" rtlCol="0" anchor="ctr"/>
           <a:lstStyle/>
           <a:p>
-            <a:pPr algn="ctr" indent="0" marL="0">
+            <a:pPr eaLnBrk="0" algn="ctr" indent="0" marL="0">
               <a:buNone/>
             </a:pPr>
             <a:r>
@@ -11746,7 +11746,7 @@
           <a:bodyPr wrap="square" lIns="0" tIns="0" rIns="0" bIns="0" rtlCol="0" anchor="ctr"/>
           <a:lstStyle/>
           <a:p>
-            <a:pPr algn="ctr" indent="0" marL="0">
+            <a:pPr eaLnBrk="0" algn="ctr" indent="0" marL="0">
               <a:buNone/>
             </a:pPr>
             <a:r>
@@ -11793,7 +11793,7 @@
           <a:bodyPr wrap="square" lIns="0" tIns="0" rIns="0" bIns="0" rtlCol="0" anchor="ctr"/>
           <a:lstStyle/>
           <a:p>
-            <a:pPr algn="ctr" indent="0" marL="0">
+            <a:pPr eaLnBrk="0" algn="ctr" indent="0" marL="0">
               <a:buNone/>
             </a:pPr>
             <a:r>
@@ -11840,7 +11840,7 @@
           <a:bodyPr wrap="square" lIns="0" tIns="0" rIns="0" bIns="0" rtlCol="0" anchor="ctr"/>
           <a:lstStyle/>
           <a:p>
-            <a:pPr algn="ctr" indent="0" marL="0">
+            <a:pPr eaLnBrk="0" algn="ctr" indent="0" marL="0">
               <a:buNone/>
             </a:pPr>
             <a:r>
@@ -11885,7 +11885,7 @@
           <a:bodyPr wrap="square" lIns="0" tIns="0" rIns="0" bIns="0" rtlCol="0" anchor="ctr"/>
           <a:lstStyle/>
           <a:p>
-            <a:pPr algn="ctr" indent="0" marL="0">
+            <a:pPr eaLnBrk="0" algn="ctr" indent="0" marL="0">
               <a:buNone/>
             </a:pPr>
             <a:r>
@@ -11924,7 +11924,7 @@
           <a:bodyPr wrap="square" lIns="0" tIns="0" rIns="0" bIns="0" rtlCol="0" anchor="t"/>
           <a:lstStyle/>
           <a:p>
-            <a:pPr algn="l" indent="0" marL="0">
+            <a:pPr eaLnBrk="0" algn="l" indent="0" marL="0">
               <a:buNone/>
             </a:pPr>
             <a:r>
@@ -11969,7 +11969,7 @@
           <a:bodyPr wrap="square" lIns="0" tIns="0" rIns="0" bIns="0" rtlCol="0" anchor="ctr"/>
           <a:lstStyle/>
           <a:p>
-            <a:pPr algn="ctr" indent="0" marL="0">
+            <a:pPr eaLnBrk="0" algn="ctr" indent="0" marL="0">
               <a:buNone/>
             </a:pPr>
             <a:r>
@@ -12008,7 +12008,7 @@
           <a:bodyPr wrap="square" lIns="0" tIns="0" rIns="0" bIns="0" rtlCol="0" anchor="t"/>
           <a:lstStyle/>
           <a:p>
-            <a:pPr algn="l" indent="0" marL="0">
+            <a:pPr eaLnBrk="0" algn="l" indent="0" marL="0">
               <a:buNone/>
             </a:pPr>
             <a:r>
@@ -12053,7 +12053,7 @@
           <a:bodyPr wrap="square" lIns="0" tIns="0" rIns="0" bIns="0" rtlCol="0" anchor="ctr"/>
           <a:lstStyle/>
           <a:p>
-            <a:pPr algn="ctr" indent="0" marL="0">
+            <a:pPr eaLnBrk="0" algn="ctr" indent="0" marL="0">
               <a:buNone/>
             </a:pPr>
             <a:r>
@@ -12092,7 +12092,7 @@
           <a:bodyPr wrap="square" lIns="0" tIns="0" rIns="0" bIns="0" rtlCol="0" anchor="t"/>
           <a:lstStyle/>
           <a:p>
-            <a:pPr algn="l" indent="0" marL="0">
+            <a:pPr eaLnBrk="0" algn="l" indent="0" marL="0">
               <a:buNone/>
             </a:pPr>
             <a:r>
@@ -12149,7 +12149,7 @@
             </a:lvl1pPr>
           </a:lstStyle>
           <a:p>
-            <a:pPr algn="r"/>
+            <a:pPr eaLnBrk="0" algn="r"/>
             <a:fld id="{F7021451-1387-4CA6-816F-3879F97B5CBC}" type="slidenum">
               <a:rPr b="0" lang="en-US"/>
               <a:t>7</a:t>
@@ -12206,7 +12206,7 @@
           <a:bodyPr wrap="square" lIns="0" tIns="0" rIns="0" bIns="0" rtlCol="0" anchor="ctr"/>
           <a:lstStyle/>
           <a:p>
-            <a:pPr algn="l" indent="0" marL="0">
+            <a:pPr eaLnBrk="0" algn="l" indent="0" marL="0">
               <a:buNone/>
             </a:pPr>
             <a:r>
@@ -12245,7 +12245,7 @@
           <a:bodyPr wrap="square" lIns="0" tIns="0" rIns="0" bIns="0" rtlCol="0" anchor="ctr"/>
           <a:lstStyle/>
           <a:p>
-            <a:pPr algn="l" indent="0" marL="0">
+            <a:pPr eaLnBrk="0" algn="l" indent="0" marL="0">
               <a:buNone/>
             </a:pPr>
             <a:r>
@@ -12311,7 +12311,7 @@
           <a:bodyPr wrap="square" lIns="0" tIns="0" rIns="0" bIns="0" rtlCol="0" anchor="ctr"/>
           <a:lstStyle/>
           <a:p>
-            <a:pPr indent="0" marL="0">
+            <a:pPr eaLnBrk="0" indent="0" marL="0">
               <a:spcAft>
                 <a:spcPts val="600"/>
               </a:spcAft>
@@ -12361,7 +12361,7 @@
           <a:bodyPr wrap="square" lIns="0" tIns="0" rIns="0" bIns="0" rtlCol="0" anchor="ctr"/>
           <a:lstStyle/>
           <a:p>
-            <a:pPr algn="ctr" indent="0" marL="0">
+            <a:pPr eaLnBrk="0" algn="ctr" indent="0" marL="0">
               <a:buNone/>
             </a:pPr>
             <a:r>
@@ -12637,7 +12637,7 @@
           <a:bodyPr wrap="square" lIns="0" tIns="0" rIns="0" bIns="0" rtlCol="0" anchor="ctr"/>
           <a:lstStyle/>
           <a:p>
-            <a:pPr algn="ctr" indent="0" marL="0">
+            <a:pPr eaLnBrk="0" algn="ctr" indent="0" marL="0">
               <a:buNone/>
             </a:pPr>
             <a:r>
@@ -12788,7 +12788,7 @@
           <a:bodyPr wrap="square" lIns="0" tIns="0" rIns="0" bIns="0" rtlCol="0" anchor="ctr"/>
           <a:lstStyle/>
           <a:p>
-            <a:pPr algn="ctr" indent="0" marL="0">
+            <a:pPr eaLnBrk="0" algn="ctr" indent="0" marL="0">
               <a:buNone/>
             </a:pPr>
             <a:r>
@@ -13208,7 +13208,7 @@
       </p:sp>
       <p:sp>
         <p:nvSpPr>
-          <p:cNvPr id="38" name="S08-figure236" descr="십 칸 틀에 6개"/>
+          <p:cNvPr id="38" name="S08-figure236" descr="1개의 십 칸 틀 중 1번째: 모두 6개"/>
           <p:cNvSpPr/>
           <p:nvPr/>
         </p:nvSpPr>
@@ -13272,7 +13272,7 @@
             </a:lvl1pPr>
           </a:lstStyle>
           <a:p>
-            <a:pPr algn="r"/>
+            <a:pPr eaLnBrk="0" algn="r"/>
             <a:fld id="{F7021451-1387-4CA6-816F-3879F97B5CBC}" type="slidenum">
               <a:rPr b="0" lang="en-US"/>
               <a:t>8</a:t>
@@ -13329,7 +13329,7 @@
           <a:bodyPr wrap="square" lIns="0" tIns="0" rIns="0" bIns="0" rtlCol="0" anchor="ctr"/>
           <a:lstStyle/>
           <a:p>
-            <a:pPr algn="l" indent="0" marL="0">
+            <a:pPr eaLnBrk="0" algn="l" indent="0" marL="0">
               <a:buNone/>
             </a:pPr>
             <a:r>
@@ -13395,7 +13395,7 @@
           <a:bodyPr wrap="square" lIns="0" tIns="0" rIns="0" bIns="0" rtlCol="0" anchor="ctr"/>
           <a:lstStyle/>
           <a:p>
-            <a:pPr indent="0" marL="0">
+            <a:pPr eaLnBrk="0" indent="0" marL="0">
               <a:spcAft>
                 <a:spcPts val="600"/>
               </a:spcAft>
@@ -13464,7 +13464,7 @@
           <a:bodyPr wrap="square" lIns="0" tIns="0" rIns="0" bIns="0" rtlCol="0" anchor="ctr"/>
           <a:lstStyle/>
           <a:p>
-            <a:pPr indent="0" marL="0">
+            <a:pPr eaLnBrk="0" indent="0" marL="0">
               <a:spcAft>
                 <a:spcPts val="600"/>
               </a:spcAft>
@@ -13514,7 +13514,7 @@
           <a:bodyPr wrap="square" lIns="177800" tIns="0" rIns="177800" bIns="0" rtlCol="0" anchor="ctr"/>
           <a:lstStyle/>
           <a:p>
-            <a:pPr algn="l" indent="0" marL="0">
+            <a:pPr eaLnBrk="0" algn="l" indent="0" marL="0">
               <a:buNone/>
             </a:pPr>
             <a:r>
@@ -13553,7 +13553,7 @@
           <a:bodyPr wrap="square" lIns="0" tIns="0" rIns="0" bIns="0" rtlCol="0" anchor="t"/>
           <a:lstStyle/>
           <a:p>
-            <a:pPr algn="l" indent="0" marL="0">
+            <a:pPr eaLnBrk="0" algn="l" indent="0" marL="0">
               <a:buNone/>
             </a:pPr>
             <a:r>
@@ -13600,7 +13600,7 @@
           <a:bodyPr wrap="square" lIns="177800" tIns="0" rIns="177800" bIns="0" rtlCol="0" anchor="ctr"/>
           <a:lstStyle/>
           <a:p>
-            <a:pPr algn="l" indent="0" marL="0">
+            <a:pPr eaLnBrk="0" algn="l" indent="0" marL="0">
               <a:buNone/>
             </a:pPr>
             <a:r>
@@ -13793,7 +13793,7 @@
           <a:bodyPr wrap="square" lIns="0" tIns="0" rIns="0" bIns="0" rtlCol="0" anchor="t"/>
           <a:lstStyle/>
           <a:p>
-            <a:pPr algn="l" indent="0" marL="0">
+            <a:pPr eaLnBrk="0" algn="l" indent="0" marL="0">
               <a:buNone/>
             </a:pPr>
             <a:r>
@@ -13850,7 +13850,7 @@
             </a:lvl1pPr>
           </a:lstStyle>
           <a:p>
-            <a:pPr algn="r"/>
+            <a:pPr eaLnBrk="0" algn="r"/>
             <a:fld id="{F7021451-1387-4CA6-816F-3879F97B5CBC}" type="slidenum">
               <a:rPr b="0" lang="en-US"/>
               <a:t>9</a:t>

</xml_diff>